<commit_message>
Reframe sales materials around recurring monthly value, not one-off gifts
Founder feedback: the sales kit and pitch deck led with one-time
occasions (graduation keepsakes, National Day) when the product is
actually priced and built as a monthly subscription — every plan is
a story allowance that resets each period, not a fixed pack.

Added an explicit "Why recurring, not one-time" section to the sales
kit (English + a condensed Arabic version), reworded the nursery use
case to lead with the ongoing monthly curriculum, added a matching
callout in pricing.md next to the plan prices, reframed the seasonal
calendar note so graduation/National Day read as moments that open a
subscription rather than define it, and updated slide 5 of the
nursery pitch deck ("One tool, many occasions" -> "Monthly, not
one-time").

Co-Authored-By: Claude Sonnet 5 <noreply@anthropic.com>
Claude-Session: https://claude.ai/code/session_01S5FXvVX5qkPC8Zv68btenQ
</commit_message>
<xml_diff>
--- a/docs/en/sales/nursery-pitch-deck.pptx
+++ b/docs/en/sales/nursery-pitch-deck.pptx
@@ -4287,7 +4287,7 @@
                 <a:ea typeface="Calibri" pitchFamily="34" charset="-122"/>
                 <a:cs typeface="Calibri" pitchFamily="34" charset="-120"/>
               </a:rPr>
-              <a:t>One tool, many occasions</a:t>
+              <a:t>Monthly, not one-time</a:t>
             </a:r>
             <a:endParaRPr lang="en-US" sz="1400" dirty="0"/>
           </a:p>
@@ -4329,7 +4329,7 @@
                 <a:ea typeface="Calibri" pitchFamily="34" charset="-122"/>
                 <a:cs typeface="Calibri" pitchFamily="34" charset="-120"/>
               </a:rPr>
-              <a:t>Classroom lessons, graduations, National Day, and parent takeaway gifts.</a:t>
+              <a:t>A new story every month, not just once at graduation.</a:t>
             </a:r>
             <a:endParaRPr lang="en-US" sz="1150" dirty="0"/>
           </a:p>

</xml_diff>